<commit_message>
Add CI/CD workflows, update tests, core services, and documentation
</commit_message>
<xml_diff>
--- a/Loan_Eligibility_Assistant.pptx
+++ b/Loan_Eligibility_Assistant.pptx
@@ -132,17 +132,33 @@
 <pc:chgInfo xmlns:a="http://schemas.openxmlformats.org/drawingml/2006/main" xmlns:r="http://schemas.openxmlformats.org/officeDocument/2006/relationships" xmlns:ac="http://schemas.microsoft.com/office/drawing/2013/main/command" xmlns:pc="http://schemas.microsoft.com/office/powerpoint/2013/main/command">
   <pc:docChgLst>
     <pc:chgData name="Mahesh Kumar" userId="98d339e7a53905f6" providerId="LiveId" clId="{1BD50F9A-90CC-46DF-ABA8-FDB7F3C2D660}"/>
-    <pc:docChg chg="custSel modSld">
-      <pc:chgData name="Mahesh Kumar" userId="98d339e7a53905f6" providerId="LiveId" clId="{1BD50F9A-90CC-46DF-ABA8-FDB7F3C2D660}" dt="2026-09-26T18:02:46.297" v="1" actId="478"/>
+    <pc:docChg chg="undo custSel modSld">
+      <pc:chgData name="Mahesh Kumar" userId="98d339e7a53905f6" providerId="LiveId" clId="{1BD50F9A-90CC-46DF-ABA8-FDB7F3C2D660}" dt="2026-09-27T10:44:29.772" v="7" actId="403"/>
       <pc:docMkLst>
         <pc:docMk/>
       </pc:docMkLst>
-      <pc:sldChg chg="delSp mod">
-        <pc:chgData name="Mahesh Kumar" userId="98d339e7a53905f6" providerId="LiveId" clId="{1BD50F9A-90CC-46DF-ABA8-FDB7F3C2D660}" dt="2026-09-26T18:02:46.297" v="1" actId="478"/>
+      <pc:sldChg chg="delSp modSp mod">
+        <pc:chgData name="Mahesh Kumar" userId="98d339e7a53905f6" providerId="LiveId" clId="{1BD50F9A-90CC-46DF-ABA8-FDB7F3C2D660}" dt="2026-09-27T10:44:29.772" v="7" actId="403"/>
         <pc:sldMkLst>
           <pc:docMk/>
           <pc:sldMk cId="0" sldId="256"/>
         </pc:sldMkLst>
+        <pc:spChg chg="mod">
+          <ac:chgData name="Mahesh Kumar" userId="98d339e7a53905f6" providerId="LiveId" clId="{1BD50F9A-90CC-46DF-ABA8-FDB7F3C2D660}" dt="2026-09-27T10:44:13.189" v="3" actId="1076"/>
+          <ac:spMkLst>
+            <pc:docMk/>
+            <pc:sldMk cId="0" sldId="256"/>
+            <ac:spMk id="2" creationId="{00000000-0000-0000-0000-000000000000}"/>
+          </ac:spMkLst>
+        </pc:spChg>
+        <pc:spChg chg="mod">
+          <ac:chgData name="Mahesh Kumar" userId="98d339e7a53905f6" providerId="LiveId" clId="{1BD50F9A-90CC-46DF-ABA8-FDB7F3C2D660}" dt="2026-09-27T10:44:15.061" v="4" actId="1076"/>
+          <ac:spMkLst>
+            <pc:docMk/>
+            <pc:sldMk cId="0" sldId="256"/>
+            <ac:spMk id="3" creationId="{00000000-0000-0000-0000-000000000000}"/>
+          </ac:spMkLst>
+        </pc:spChg>
         <pc:spChg chg="del">
           <ac:chgData name="Mahesh Kumar" userId="98d339e7a53905f6" providerId="LiveId" clId="{1BD50F9A-90CC-46DF-ABA8-FDB7F3C2D660}" dt="2026-09-26T18:02:44.557" v="0" actId="478"/>
           <ac:spMkLst>
@@ -157,6 +173,22 @@
             <pc:docMk/>
             <pc:sldMk cId="0" sldId="256"/>
             <ac:spMk id="5" creationId="{00000000-0000-0000-0000-000000000000}"/>
+          </ac:spMkLst>
+        </pc:spChg>
+        <pc:spChg chg="mod">
+          <ac:chgData name="Mahesh Kumar" userId="98d339e7a53905f6" providerId="LiveId" clId="{1BD50F9A-90CC-46DF-ABA8-FDB7F3C2D660}" dt="2026-09-27T10:44:18.664" v="5" actId="1076"/>
+          <ac:spMkLst>
+            <pc:docMk/>
+            <pc:sldMk cId="0" sldId="256"/>
+            <ac:spMk id="6" creationId="{00000000-0000-0000-0000-000000000000}"/>
+          </ac:spMkLst>
+        </pc:spChg>
+        <pc:spChg chg="mod">
+          <ac:chgData name="Mahesh Kumar" userId="98d339e7a53905f6" providerId="LiveId" clId="{1BD50F9A-90CC-46DF-ABA8-FDB7F3C2D660}" dt="2026-09-27T10:44:29.772" v="7" actId="403"/>
+          <ac:spMkLst>
+            <pc:docMk/>
+            <pc:sldMk cId="0" sldId="256"/>
+            <ac:spMk id="7" creationId="{00000000-0000-0000-0000-000000000000}"/>
           </ac:spMkLst>
         </pc:spChg>
       </pc:sldChg>
@@ -3186,7 +3218,7 @@
         </p:nvSpPr>
         <p:spPr>
           <a:xfrm>
-            <a:off x="594360" y="329184"/>
+            <a:off x="580644" y="564642"/>
             <a:ext cx="11000232" cy="22860"/>
           </a:xfrm>
           <a:prstGeom prst="rect">
@@ -3230,7 +3262,7 @@
         </p:nvSpPr>
         <p:spPr>
           <a:xfrm>
-            <a:off x="594360" y="640080"/>
+            <a:off x="580644" y="108425"/>
             <a:ext cx="11000232" cy="420624"/>
           </a:xfrm>
           <a:prstGeom prst="rect">
@@ -3265,8 +3297,8 @@
         </p:nvSpPr>
         <p:spPr>
           <a:xfrm>
-            <a:off x="594360" y="1097280"/>
-            <a:ext cx="11000232" cy="256032"/>
+            <a:off x="717804" y="876521"/>
+            <a:ext cx="11000232" cy="215444"/>
           </a:xfrm>
           <a:prstGeom prst="rect">
             <a:avLst/>
@@ -3281,7 +3313,7 @@
           <a:p>
             <a:pPr algn="l"/>
             <a:r>
-              <a:rPr sz="1300" b="0" i="0">
+              <a:rPr sz="1400" b="0" i="0" dirty="0">
                 <a:solidFill>
                   <a:srgbClr val="5B6B85"/>
                 </a:solidFill>
@@ -4698,13 +4730,13 @@
           <a:p>
             <a:pPr algn="l"/>
             <a:r>
-              <a:rPr sz="919" b="0" i="0">
+              <a:rPr sz="919" b="0">
                 <a:solidFill>
                   <a:srgbClr val="8595AC"/>
                 </a:solidFill>
                 <a:latin typeface="Calibri"/>
               </a:rPr>
-              <a:t>Comprehensive Retail Lending Coverage · 3 Products · 40 Versioned Policy Clauses</a:t>
+              <a:t>Comprehensive Retail Lending Coverage · 3 Products · Co-Applicant Pooling · 40 Versioned Policy Clauses</a:t>
             </a:r>
           </a:p>
         </p:txBody>
@@ -5206,7 +5238,7 @@
                 </a:solidFill>
                 <a:latin typeface="Calibri"/>
               </a:rPr>
-              <a:t> — Age 21–65, Income ≥₹40K, CIBIL ≥700</a:t>
+              <a:t> — Age 21–65, Income ≥₹40K (or Joint Pooled), CIBIL ≥700</a:t>
             </a:r>
           </a:p>
           <a:p>
@@ -5222,7 +5254,7 @@
                 </a:solidFill>
                 <a:latin typeface="Calibri"/>
               </a:rPr>
-              <a:t>• LTV &amp; Margin</a:t>
+              <a:t>• Joint Applicants</a:t>
             </a:r>
             <a:r>
               <a:rPr sz="1019" b="0">
@@ -5231,7 +5263,7 @@
                 </a:solidFill>
                 <a:latin typeface="Calibri"/>
               </a:rPr>
-              <a:t> — Up to 80% property value; ≥20% down payment</a:t>
+              <a:t> — Co-applicant income &amp; EMI pooling to expand loan power</a:t>
             </a:r>
           </a:p>
           <a:p>
@@ -5247,7 +5279,7 @@
                 </a:solidFill>
                 <a:latin typeface="Calibri"/>
               </a:rPr>
-              <a:t>• Tenure &amp; Rate</a:t>
+              <a:t>• LTV &amp; Rate</a:t>
             </a:r>
             <a:r>
               <a:rPr sz="1019" b="0">
@@ -5256,7 +5288,7 @@
                 </a:solidFill>
                 <a:latin typeface="Calibri"/>
               </a:rPr>
-              <a:t> — 5 to 30 years · 8.5% p.a. benchmark</a:t>
+              <a:t> — Up to 80% property value · 8.5% p.a. (up to 30 yrs)</a:t>
             </a:r>
           </a:p>
         </p:txBody>
@@ -5854,13 +5886,13 @@
           <a:p>
             <a:pPr algn="l"/>
             <a:r>
-              <a:rPr sz="960" b="0" i="0">
+              <a:rPr sz="960" b="0">
                 <a:solidFill>
                   <a:srgbClr val="334155"/>
                 </a:solidFill>
                 <a:latin typeface="Calibri"/>
               </a:rPr>
-              <a:t>Captures profile details progressively across the chat and merges them — never asking the customer to repeat known information.</a:t>
+              <a:t>Captures profile details (including co-applicants) progressively across multi-turn chat and merges them — never re-asking known info.</a:t>
             </a:r>
           </a:p>
         </p:txBody>
@@ -5983,13 +6015,13 @@
           <a:p>
             <a:pPr algn="l"/>
             <a:r>
-              <a:rPr sz="1100" b="1" i="0">
+              <a:rPr sz="1100" b="1">
                 <a:solidFill>
                   <a:srgbClr val="B5651D"/>
                 </a:solidFill>
                 <a:latin typeface="Calibri"/>
               </a:rPr>
-              <a:t>Instant 'What-If' Affordability Advice</a:t>
+              <a:t>Adverse-Action Remediation Advice</a:t>
             </a:r>
           </a:p>
         </p:txBody>
@@ -6018,13 +6050,13 @@
           <a:p>
             <a:pPr algn="l"/>
             <a:r>
-              <a:rPr sz="960" b="0" i="0">
+              <a:rPr sz="960" b="0">
                 <a:solidFill>
                   <a:srgbClr val="334155"/>
                 </a:solidFill>
                 <a:latin typeface="Calibri"/>
               </a:rPr>
-              <a:t>When a borrower falls short, the assistant calculates their maximum affordable loan or shows how a higher down payment unlocks eligibility.</a:t>
+              <a:t>When a borrower falls short, the deterministic engine calculates 4 exact remediation pathways: lower loan, longer tenure, EMI clearance, or co-applicant.</a:t>
             </a:r>
           </a:p>
         </p:txBody>
@@ -6638,13 +6670,13 @@
           <a:p>
             <a:pPr algn="l"/>
             <a:r>
-              <a:rPr sz="919" b="0" i="0">
+              <a:rPr sz="919" b="0">
                 <a:solidFill>
                   <a:srgbClr val="8595AC"/>
                 </a:solidFill>
                 <a:latin typeface="Calibri"/>
               </a:rPr>
-              <a:t>Neuro-Symbolic Architecture · Zero AI Math Guesswork · Hot-Swappable Policy Versions</a:t>
+              <a:t>Neuro-Symbolic Architecture · Hybrid RAG (Dense + BM25) · Automated Remediation Solver</a:t>
             </a:r>
           </a:p>
         </p:txBody>
@@ -6896,15 +6928,15 @@
           <a:p>
             <a:pPr algn="l"/>
             <a:r>
-              <a:rPr sz="1019" b="0" i="0">
+              <a:rPr sz="1019" b="0">
                 <a:solidFill>
                   <a:srgbClr val="334155"/>
                 </a:solidFill>
                 <a:latin typeface="Calibri"/>
               </a:rPr>
-              <a:t>• Identifies loan product from natural phrasing
-• Extracts income, age, CIBIL &amp; collateral details
-• Merges with earlier conversation turns</a:t>
+              <a:t>• Identifies loan product &amp; informational FAQ intent
+• Extracts primary + co-applicant income &amp; obligations
+• Merges multi-turn profile context dynamically</a:t>
             </a:r>
           </a:p>
         </p:txBody>
@@ -7121,15 +7153,15 @@
           <a:p>
             <a:pPr algn="l"/>
             <a:r>
-              <a:rPr sz="1019" b="0" i="0">
+              <a:rPr sz="1019" b="0">
                 <a:solidFill>
                   <a:srgbClr val="FFFFFF"/>
                 </a:solidFill>
                 <a:latin typeface="Calibri"/>
               </a:rPr>
-              <a:t>• Calculates exact monthly EMI, FOIR &amp; LTV
-• Evaluates all 25 product policy thresholds
-• Computes maximum affordable loan amount</a:t>
+              <a:t>• Pools household income &amp; calculates EMI, FOIR &amp; LTV
+• Evaluates all 25+ product policy rules deterministically
+• Solves adverse-action remediation &amp; max affordable loan</a:t>
             </a:r>
           </a:p>
         </p:txBody>
@@ -7311,13 +7343,13 @@
           <a:p>
             <a:pPr algn="l"/>
             <a:r>
-              <a:rPr sz="950" b="1" i="0">
+              <a:rPr sz="950" b="1">
                 <a:solidFill>
                   <a:srgbClr val="5B6B85"/>
                 </a:solidFill>
                 <a:latin typeface="Calibri"/>
               </a:rPr>
-              <a:t>Versioned Policy Knowledge Base</a:t>
+              <a:t>Hybrid RAG &amp; Semantic FAQ Cache</a:t>
             </a:r>
           </a:p>
         </p:txBody>
@@ -7346,15 +7378,15 @@
           <a:p>
             <a:pPr algn="l"/>
             <a:r>
-              <a:rPr sz="1019" b="0" i="0">
+              <a:rPr sz="1019" b="0">
                 <a:solidFill>
                   <a:srgbClr val="334155"/>
                 </a:solidFill>
                 <a:latin typeface="Calibri"/>
               </a:rPr>
-              <a:t>• Pulls only the active policy version (v1 or v2)
-• Matches exact Rule IDs to every check
-• Prevents outdated rules from leaking in</a:t>
+              <a:t>• Hybrid retrieval: Dense ChromaDB + BM25 with RRF &amp; boost
+• Sub-15ms semantic FAQ cache for common policy queries
+• Version-locked policy isolation (v1/v2) prevents drift</a:t>
             </a:r>
           </a:p>
         </p:txBody>
@@ -7571,15 +7603,15 @@
           <a:p>
             <a:pPr algn="l"/>
             <a:r>
-              <a:rPr sz="1019" b="0" i="0">
+              <a:rPr sz="1019" b="0">
                 <a:solidFill>
                   <a:srgbClr val="334155"/>
                 </a:solidFill>
                 <a:latin typeface="Calibri"/>
               </a:rPr>
-              <a:t>• Streams a clear, plain-language explanation
-• Attaches verified policy Rule ID citations
-• Records a complete, privacy-masked audit log</a:t>
+              <a:t>• Streams explanation with structured remediation options
+• Attaches verified policy Rule ID citations &amp; cards
+• DPDP Act (2023) consent, PII masking &amp; sliding sessions</a:t>
             </a:r>
           </a:p>
         </p:txBody>
@@ -8300,13 +8332,13 @@
           <a:p>
             <a:pPr algn="l"/>
             <a:r>
-              <a:rPr sz="919" b="0" i="0">
+              <a:rPr sz="919" b="0">
                 <a:solidFill>
                   <a:srgbClr val="8595AC"/>
                 </a:solidFill>
                 <a:latin typeface="Calibri"/>
               </a:rPr>
-              <a:t>Live Demo Scenario · Multi-Turn Home Loan &amp; What-If Affordability Walkthrough</a:t>
+              <a:t>Live Demo Scenario · Multi-Turn Home Loan, Co-Applicant &amp; Remediation Walkthrough</a:t>
             </a:r>
           </a:p>
         </p:txBody>
@@ -8747,7 +8779,7 @@
           <a:p>
             <a:pPr algn="l"/>
             <a:r>
-              <a:rPr sz="980" b="0" i="0">
+              <a:rPr sz="1019" b="0">
                 <a:solidFill>
                   <a:srgbClr val="334155"/>
                 </a:solidFill>
@@ -8755,7 +8787,7 @@
               </a:rPr>
               <a:t>• Combines Turn 1 + Turn 2 details seamlessly without re-asking a single field.
 • Displays exact KPIs: Monthly EMI ₹52,069 · Obligation Ratio (FOIR) 50% · Property LTV 75%.
-• Cites Home Loan Policy v2 rules (Age, Income, CIBIL, FOIR, LTV) in an expandable audit card.</a:t>
+• Auto-generates adverse-action remediation options if ineligible (lower loan, tenure, or co-borrower).</a:t>
             </a:r>
           </a:p>
         </p:txBody>
@@ -9209,13 +9241,13 @@
           <a:p>
             <a:pPr algn="l"/>
             <a:r>
-              <a:rPr sz="880" b="0" i="0">
+              <a:rPr sz="880" b="0">
                 <a:solidFill>
                   <a:srgbClr val="334155"/>
                 </a:solidFill>
                 <a:latin typeface="Calibri"/>
               </a:rPr>
-              <a:t>Explains exact failed rule + how to qualify</a:t>
+              <a:t>Adverse-Action Remediation: exact math to qualify</a:t>
             </a:r>
           </a:p>
         </p:txBody>
@@ -9611,13 +9643,13 @@
           <a:p>
             <a:pPr algn="l"/>
             <a:r>
-              <a:rPr sz="1300" b="0" i="0">
+              <a:rPr sz="1300" b="0">
                 <a:solidFill>
                   <a:srgbClr val="FFFFFF"/>
                 </a:solidFill>
                 <a:latin typeface="Cambria"/>
               </a:rPr>
-              <a:t>Even when a borrower is Not Eligible today, LoanAssist shows the exact loan amount or down payment that works.</a:t>
+              <a:t>Even when a borrower is Not Eligible today, LoanAssist generates concrete remediation pathways: loan reduction, tenure extension, or co-applicant pooling.</a:t>
             </a:r>
           </a:p>
         </p:txBody>
@@ -9901,13 +9933,13 @@
           <a:p>
             <a:pPr algn="l"/>
             <a:r>
-              <a:rPr sz="919" b="0" i="0">
+              <a:rPr sz="919" b="0">
                 <a:solidFill>
                   <a:srgbClr val="8595AC"/>
                 </a:solidFill>
                 <a:latin typeface="Calibri"/>
               </a:rPr>
-              <a:t>Enterprise Controls · 80 Automated Unit Tests · 15 End-to-End Evaluation Gates · Full JSONL Audit Trail</a:t>
+              <a:t>Enterprise Controls · 96 Automated Tests · RAG Triad Benchmarks · DPDP Act Compliance</a:t>
             </a:r>
           </a:p>
         </p:txBody>
@@ -10325,13 +10357,13 @@
           <a:p>
             <a:pPr algn="l"/>
             <a:r>
-              <a:rPr sz="2400" b="1" i="0">
+              <a:rPr sz="2400" b="1">
                 <a:solidFill>
                   <a:srgbClr val="B5651D"/>
                 </a:solidFill>
                 <a:latin typeface="Cambria"/>
               </a:rPr>
-              <a:t>80 / 80</a:t>
+              <a:t>96 / 96</a:t>
             </a:r>
           </a:p>
         </p:txBody>
@@ -10360,13 +10392,13 @@
           <a:p>
             <a:pPr algn="l"/>
             <a:r>
-              <a:rPr sz="1080" b="1" i="0">
+              <a:rPr sz="1080" b="1">
                 <a:solidFill>
                   <a:srgbClr val="0E1E38"/>
                 </a:solidFill>
                 <a:latin typeface="Calibri"/>
               </a:rPr>
-              <a:t>Automated Rule Tests Passing</a:t>
+              <a:t>Automated Tests &amp; Benchmarks</a:t>
             </a:r>
           </a:p>
         </p:txBody>
@@ -10395,13 +10427,13 @@
           <a:p>
             <a:pPr algn="l"/>
             <a:r>
-              <a:rPr sz="919" b="0" i="0">
+              <a:rPr sz="919" b="0">
                 <a:solidFill>
                   <a:srgbClr val="5B6B85"/>
                 </a:solidFill>
                 <a:latin typeface="Calibri"/>
               </a:rPr>
-              <a:t>Covers all 3 loan products</a:t>
+              <a:t>Rules, calculators, pooling &amp; RAG</a:t>
             </a:r>
           </a:p>
         </p:txBody>
@@ -10847,13 +10879,13 @@
           <a:p>
             <a:pPr algn="l"/>
             <a:r>
-              <a:rPr sz="1250" b="1" i="0">
+              <a:rPr sz="1250" b="1">
                 <a:solidFill>
                   <a:srgbClr val="1B3A6B"/>
                 </a:solidFill>
                 <a:latin typeface="Calibri"/>
               </a:rPr>
-              <a:t>2. Privacy &amp; Regulator-Ready Audit</a:t>
+              <a:t>2. Privacy, DPDP Act &amp; Regulator Audit</a:t>
             </a:r>
           </a:p>
         </p:txBody>
@@ -10892,7 +10924,7 @@
                 </a:solidFill>
                 <a:latin typeface="Calibri"/>
               </a:rPr>
-              <a:t>• Automatic PII Masking</a:t>
+              <a:t>• DPDP Act (2023) Compliance</a:t>
             </a:r>
             <a:r>
               <a:rPr sz="1000" b="0">
@@ -10901,7 +10933,7 @@
                 </a:solidFill>
                 <a:latin typeface="Calibri"/>
               </a:rPr>
-              <a:t> — Redacts PAN, Aadhaar, mobile numbers, emails, and account numbers before writing any log.</a:t>
+              <a:t> — Explicit consent banner, right to clear data, and sliding-TTL session lifecycle.</a:t>
             </a:r>
           </a:p>
           <a:p>
@@ -10917,7 +10949,7 @@
                 </a:solidFill>
                 <a:latin typeface="Calibri"/>
               </a:rPr>
-              <a:t>• Version-Stamped Trail</a:t>
+              <a:t>• Automatic PII Masking</a:t>
             </a:r>
             <a:r>
               <a:rPr sz="1000" b="0">
@@ -10926,7 +10958,7 @@
                 </a:solidFill>
                 <a:latin typeface="Calibri"/>
               </a:rPr>
-              <a:t> — Every decision logs the exact Policy ID, Policy Version (v1/v2), rule checks, and timestamp.</a:t>
+              <a:t> — Redacts PAN, Aadhaar, mobile numbers, and bank account numbers prior to logging.</a:t>
             </a:r>
           </a:p>
           <a:p>
@@ -10942,7 +10974,7 @@
                 </a:solidFill>
                 <a:latin typeface="Calibri"/>
               </a:rPr>
-              <a:t>• Live Operational Telemetry</a:t>
+              <a:t>• Complete Audit Trail</a:t>
             </a:r>
             <a:r>
               <a:rPr sz="1000" b="0">
@@ -10951,7 +10983,7 @@
                 </a:solidFill>
                 <a:latin typeface="Calibri"/>
               </a:rPr>
-              <a:t> — Real-time dashboards track traffic volume, response speed, and decision outcomes.</a:t>
+              <a:t> — Every decision logs exact Policy ID, Rule IDs, remediation options &amp; timestamped telemetry.</a:t>
             </a:r>
           </a:p>
         </p:txBody>
@@ -11028,13 +11060,13 @@
           <a:p>
             <a:pPr algn="l"/>
             <a:r>
-              <a:rPr sz="1250" b="1" i="0">
+              <a:rPr sz="1250" b="1">
                 <a:solidFill>
                   <a:srgbClr val="B5651D"/>
                 </a:solidFill>
                 <a:latin typeface="Calibri"/>
               </a:rPr>
-              <a:t>3. Automated Release Protection</a:t>
+              <a:t>3. RAG Triad &amp; Automated Release Quality</a:t>
             </a:r>
           </a:p>
         </p:txBody>
@@ -11073,7 +11105,7 @@
                 </a:solidFill>
                 <a:latin typeface="Calibri"/>
               </a:rPr>
-              <a:t>• Tested on Every Change</a:t>
+              <a:t>• 96 Automated Tests</a:t>
             </a:r>
             <a:r>
               <a:rPr sz="1000" b="0">
@@ -11082,7 +11114,7 @@
                 </a:solidFill>
                 <a:latin typeface="Calibri"/>
               </a:rPr>
-              <a:t> — 80 unit tests verify EMI math and policy boundaries on every single code push.</a:t>
+              <a:t> — Verifies EMI math, rules, co-applicant pooling, and remediation on every single code push.</a:t>
             </a:r>
           </a:p>
           <a:p>
@@ -11098,7 +11130,7 @@
                 </a:solidFill>
                 <a:latin typeface="Calibri"/>
               </a:rPr>
-              <a:t>• Pre-Merge Quality Gate</a:t>
+              <a:t>• Quantitative RAG Triad</a:t>
             </a:r>
             <a:r>
               <a:rPr sz="1000" b="0">
@@ -11107,7 +11139,7 @@
                 </a:solidFill>
                 <a:latin typeface="Calibri"/>
               </a:rPr>
-              <a:t> — 15 end-to-end customer scenarios test Personal, Home, and Auto loan accuracy automatically.</a:t>
+              <a:t> — Evaluates Context Relevance, Groundedness/Faithfulness &amp; Answer Relevance benchmarks.</a:t>
             </a:r>
           </a:p>
           <a:p>
@@ -11123,7 +11155,7 @@
                 </a:solidFill>
                 <a:latin typeface="Calibri"/>
               </a:rPr>
-              <a:t>• Blocks Policy Drift</a:t>
+              <a:t>• Pre-Merge Quality Gate</a:t>
             </a:r>
             <a:r>
               <a:rPr sz="1000" b="0">
@@ -11132,7 +11164,7 @@
                 </a:solidFill>
                 <a:latin typeface="Calibri"/>
               </a:rPr>
-              <a:t> — If a change accidentally weakens a credit rule or breaks a citation, deployment is blocked.</a:t>
+              <a:t> — 15 end-to-end customer scenarios block policy drift and ungrounded claims automatically.</a:t>
             </a:r>
           </a:p>
         </p:txBody>
@@ -11789,7 +11821,7 @@
                 </a:solidFill>
                 <a:latin typeface="Calibri"/>
               </a:rPr>
-              <a:t> — Compresses a 15-minute manual policy check into a &lt;60-second self-service digital conversation.</a:t>
+              <a:t> — Compresses policy checks into &lt;60s chat with sub-15ms cached FAQ responses.</a:t>
             </a:r>
           </a:p>
           <a:p>
@@ -11805,7 +11837,7 @@
                 </a:solidFill>
                 <a:latin typeface="Calibri"/>
               </a:rPr>
-              <a:t>• Three Retail Products in One Chat</a:t>
+              <a:t>• Three Retail Products + Co-Applicant Pooling</a:t>
             </a:r>
             <a:r>
               <a:rPr sz="1050" b="0">
@@ -11814,7 +11846,7 @@
                 </a:solidFill>
                 <a:latin typeface="Calibri"/>
               </a:rPr>
-              <a:t> — Covers Personal Loans, Home Loans, and Auto Loans (Cars, 2-Wheelers, Commercial &amp; EVs) seamlessly.</a:t>
+              <a:t> — Covers Personal, Home &amp; Auto loans with joint household income &amp; EMI pooling.</a:t>
             </a:r>
           </a:p>
           <a:p>
@@ -11830,7 +11862,7 @@
                 </a:solidFill>
                 <a:latin typeface="Calibri"/>
               </a:rPr>
-              <a:t>• Higher Borrower Conversion</a:t>
+              <a:t>• Automated Adverse-Action Remediation</a:t>
             </a:r>
             <a:r>
               <a:rPr sz="1050" b="0">
@@ -11839,7 +11871,7 @@
                 </a:solidFill>
                 <a:latin typeface="Calibri"/>
               </a:rPr>
-              <a:t> — Interactive 'What-If' affordability guidance retains customers who need to adjust loan amount or tenure.</a:t>
+              <a:t> — Retains and converts ineligible borrowers via algorithmic counter-offers &amp; pathways.</a:t>
             </a:r>
           </a:p>
           <a:p>
@@ -11855,7 +11887,7 @@
                 </a:solidFill>
                 <a:latin typeface="Calibri"/>
               </a:rPr>
-              <a:t>• 100% Policy &amp; Calculation Consistency</a:t>
+              <a:t>• 100% Policy &amp; Math Consistency</a:t>
             </a:r>
             <a:r>
               <a:rPr sz="1050" b="0">
@@ -11864,7 +11896,7 @@
                 </a:solidFill>
                 <a:latin typeface="Calibri"/>
               </a:rPr>
-              <a:t> — Eliminates human interpretation gaps and AI math errors with deterministic rule execution.</a:t>
+              <a:t> — Hybrid RAG (BM25 + Dense) and deterministic rules eliminate hallucinations.</a:t>
             </a:r>
           </a:p>
           <a:p>
@@ -11880,7 +11912,7 @@
                 </a:solidFill>
                 <a:latin typeface="Calibri"/>
               </a:rPr>
-              <a:t>• Zero Data Egress Privacy</a:t>
+              <a:t>• DPDP Act (2023) Compliance &amp; Privacy</a:t>
             </a:r>
             <a:r>
               <a:rPr sz="1050" b="0">
@@ -11889,7 +11921,7 @@
                 </a:solidFill>
                 <a:latin typeface="Calibri"/>
               </a:rPr>
-              <a:t> — Capable of running entirely on local infrastructure so sensitive financial data never leaves the bank.</a:t>
+              <a:t> — Sliding-TTL session store, explicit consent banner, and automated PII redaction.</a:t>
             </a:r>
           </a:p>
         </p:txBody>
@@ -12322,7 +12354,7 @@
           <a:p>
             <a:pPr algn="l"/>
             <a:r>
-              <a:rPr sz="980" b="0" i="0">
+              <a:rPr sz="980" b="0">
                 <a:solidFill>
                   <a:srgbClr val="334155"/>
                 </a:solidFill>
@@ -12330,7 +12362,7 @@
               </a:rPr>
               <a:t>• Connect live Credit Bureau (CIBIL / Experian) and Account Aggregator APIs
 • Add automated OCR verification for pay slips, bank statements &amp; vehicle quotes
-• Introduce joint co-applicant income pooling for Home Loans</a:t>
+• Pre-approved offer matching &amp; automated interest rate discount engine</a:t>
             </a:r>
           </a:p>
         </p:txBody>

</xml_diff>